<commit_message>
docs(readme): bench à jour
</commit_message>
<xml_diff>
--- a/Livrables/benchHarness/Bench_Coding-Agentique.pptx
+++ b/Livrables/benchHarness/Bench_Coding-Agentique.pptx
@@ -574,7 +574,7 @@
           <a:lstStyle/>
           <a:p>
             <a:r>
-              <a:t>La problematique de deploiement : les prestataires externes peuvent rester sur leur abonnement Claude (forfait mensuel, consommation incluse, cout previsible). Les agents internes, eux, demarreront a environ 20 euros par siege et par mois (sieges Claude Enterprise via Bedrock), auxquels s'ajoute chaque token consomme, facture au prix du modele. Le cout interne suit donc l'usage, et l'usage agentique est intensif en tokens. Consequence : optimiser le cout au token (choix du modele, du harness, caching) devient le parametre cle pour les internes et pour la CI/CD - c'est ce que le bench compare, et ce que le bench elargi en conditions reelles validera (scenario Albert/DeepSeek via OpenCode face a Claude avec et sans abonnement).</a:t>
+              <a:t>Gradation de souverainete : Albert (Etat FR, SecNumCloud) &gt; Opus 4.8 via Bedrock (partielle, sensible au CLOUD Act) &gt; Opus 4.8 via Anthropic et GLM/DeepSeek via OpenRouter (non souveraines, a reserver eventuellement aux externes). Albert s'utilise avec OpenCode : guide officiel DINUM guides.ia.numerique.gouv.fr/albert-api/guides/ide#agentic-coding-opencode. La problematique de deploiement : les prestataires externes peuvent rester sur leur abonnement Claude (forfait mensuel, consommation incluse, cout previsible). Les agents internes, eux, demarreront a environ 20 euros par siege et par mois (sieges Claude Enterprise via Bedrock), auxquels s'ajoute chaque token consomme, facture au prix du modele. Le cout interne suit donc l'usage, et l'usage agentique est intensif en tokens. Consequence : optimiser le cout au token (choix du modele, du harness, caching) devient le parametre cle pour les internes et pour la CI/CD - c'est ce que le bench compare, et ce que le bench elargi en conditions reelles validera (scenario Albert/DeepSeek via OpenCode face a Claude avec et sans abonnement).</a:t>
             </a:r>
           </a:p>
         </p:txBody>
@@ -7800,7 +7800,7 @@
                 </a:solidFill>
                 <a:latin typeface="Marianne"/>
               </a:rPr>
-              <a:t>Sièges Claude Enterprise via Bedrock : la consommation s'ajoute au siège</a:t>
+              <a:t>Sièges Claude Enterprise via Bedrock</a:t>
             </a:r>
           </a:p>
           <a:p>
@@ -7831,7 +7831,38 @@
                 </a:solidFill>
                 <a:latin typeface="Marianne"/>
               </a:rPr>
-              <a:t>Le coût suit l'usage, et l'agentique consomme beaucoup de tokens</a:t>
+              <a:t>Coût à l'usage : l'agentique consomme beaucoup</a:t>
+            </a:r>
+          </a:p>
+          <a:p>
+            <a:pPr algn="l" marL="201168" indent="-201168">
+              <a:lnSpc>
+                <a:spcPct val="108000"/>
+              </a:lnSpc>
+              <a:spcBef>
+                <a:spcPts val="0"/>
+              </a:spcBef>
+              <a:spcAft>
+                <a:spcPts val="600"/>
+              </a:spcAft>
+            </a:pPr>
+            <a:r>
+              <a:rPr sz="1200" b="0" i="0">
+                <a:solidFill>
+                  <a:srgbClr val="6A6AF4"/>
+                </a:solidFill>
+                <a:latin typeface="Marianne"/>
+              </a:rPr>
+              <a:t>▪  </a:t>
+            </a:r>
+            <a:r>
+              <a:rPr sz="1300" b="0" i="0">
+                <a:solidFill>
+                  <a:srgbClr val="3A3A3A"/>
+                </a:solidFill>
+                <a:latin typeface="Marianne"/>
+              </a:rPr>
+              <a:t>Souveraineté partielle : sensible au CLOUD Act</a:t>
             </a:r>
           </a:p>
         </p:txBody>
@@ -9562,7 +9593,7 @@
                 </a:solidFill>
                 <a:latin typeface="Marianne"/>
               </a:rPr>
-              <a:t>À valider : </a:t>
+              <a:t>À noter : </a:t>
             </a:r>
             <a:r>
               <a:rPr sz="1000" b="0" i="1">
@@ -9571,7 +9602,7 @@
                 </a:solidFill>
                 <a:latin typeface="Marianne"/>
               </a:rPr>
-              <a:t>catalogue Albert à confirmer via /v1/models · DeepSeek V4 = tarif preview · tarifs OpenRouter = catalogue (caching −60/80 %) · tokenizer Opus 4.8 ≈ +30 % de tokens.</a:t>
+              <a:t>OpenCode + Albert est documenté officiellement par la DINUM (guides.ia.numerique.gouv.fr) · catalogue Albert à confirmer via /v1/models · DeepSeek V4 = tarif preview · tarifs OpenRouter = catalogue (caching −60/80 %) · tokenizer Opus 4.8 ≈ +30 % de tokens.</a:t>
             </a:r>
           </a:p>
         </p:txBody>

</xml_diff>